<commit_message>
Add MICrONS-reliance + Nature (2025) impact to outreach/acknowledgments slides
MICrONS depended on this student proofreading workforce throughout; their work
underpins the MICrONS connectome (Nature 2025) and downstream contributions.

Co-Authored-By: Claude Opus 4.8 <noreply@anthropic.com>
Claude-Session: https://claude.ai/code/session_01FUsW3Vrx4pctYUtsvYQpE9
</commit_message>
<xml_diff>
--- a/talk/berlin_deck_v3.pptx
+++ b/talk/berlin_deck_v3.pptx
@@ -6887,7 +6887,14 @@
             <a:pPr lvl="1"/>
             <a:r>
               <a:rPr sz="1500"/>
-              <a:t>Several novices became top-throughput proofreaders credited in MICrONS; eight were promoted to expert tasks.</a:t>
+              <a:t>MICrONS relied on this student workforce throughout — their proofreading underpins the MICrONS connectome (Nature, 2025) and downstream contributions.</a:t>
+            </a:r>
+          </a:p>
+          <a:p>
+            <a:pPr lvl="1"/>
+            <a:r>
+              <a:rPr sz="1500"/>
+              <a:t>Several novices were top-throughput proofreaders credited in MICrONS; eight were promoted to expert tasks.</a:t>
             </a:r>
           </a:p>
           <a:p>
@@ -7011,7 +7018,7 @@
             <a:pPr lvl="1"/>
             <a:r>
               <a:rPr sz="1500"/>
-              <a:t>Datasets &amp; methods — MICrONS Consortium; Matelsky &amp; Gray-Roncal (consequence-of-edits / motif census); Sanchez et al., Connectomics Annotation Metadata Standardization (Front. Neuroinform. 2022); H01 / CONNECTS-Proof.</a:t>
+              <a:t>Datasets &amp; methods — MICrONS Consortium (Nature, 2025); Matelsky &amp; Gray-Roncal (consequence-of-edits / motif census); Sanchez et al., Connectomics Annotation Metadata Standardization (Front. Neuroinform. 2022); H01 / CONNECTS-Proof.</a:t>
             </a:r>
           </a:p>
           <a:p>

</xml_diff>

<commit_message>
Item 1 (prospective GT-free competence) + figures + JIGSAWS framing + Xenes/co-author emphasis
- mine_predictive_separability: annotator-level simple behavior does NOT separate competence
  (LOO AUC 0.14, honest negative); per-task 'slow-for-this-person' weakly flags errors GT-free
  (AUC 0.59, p<0.001) = subconscious uncertainty. Bad tail lacks dense telemetry.
- figures: tier-AUC, learned motif dictionary, two-task accuracy, separability/uncertainty
- slide C: language of proofreading <-> language of surgery (JIGSAWS, tacit knowledge)
- outreach slide: hired students -> co-authors/contributing members (Daniel Xenes exemplar)
- methodology S13 + deck_expansion: item-1 results, framing, data limits

Co-Authored-By: Claude Opus 4.8 <noreply@anthropic.com>
Claude-Session: https://claude.ai/code/session_01FUsW3Vrx4pctYUtsvYQpE9
</commit_message>
<xml_diff>
--- a/talk/berlin_deck_v3.pptx
+++ b/talk/berlin_deck_v3.pptx
@@ -890,7 +890,7 @@
           <a:lstStyle/>
           <a:p>
             <a:r>
-              <a:t>Retrospective, and experts-vs-proto-experts (conservative). The pre-registered predictive test is this summer.</a:t>
+              <a:t>Style separation is retrospective; the per-task GT-free signal is small (AUC ~0.59) and the prospective test is this summer. Honest negative: annotator-level simple-behavior separability FAILED (LOO AUC 0.14).</a:t>
             </a:r>
           </a:p>
         </p:txBody>
@@ -960,7 +960,7 @@
           <a:lstStyle/>
           <a:p>
             <a:r>
-              <a:t>LENS = humans + outcomes. New framing (Gray-Roncal, Research Incubator): students as a METHOD for mission impact.</a:t>
+              <a:t>Dual yield is structurally identical — talent development and mission acceleration are the same act. LENS = humans + outcomes; students as a METHOD (Gray-Roncal, Research Incubator).</a:t>
             </a:r>
           </a:p>
         </p:txBody>
@@ -6749,42 +6749,42 @@
             <a:pPr lvl="1"/>
             <a:r>
               <a:rPr sz="1500"/>
-              <a:t>Dense per-event telemetry (multiSomaId): every navigate / edit / annotate, with 3D camera motion.</a:t>
+              <a:t>Dense per-event telemetry: every navigate / edit / annotate, with 3D camera motion.</a:t>
             </a:r>
           </a:p>
           <a:p>
             <a:pPr lvl="1"/>
             <a:r>
               <a:rPr sz="1500"/>
-              <a:t>Behavior separates experts from proto-experts: naive counts AUC 0.75 → designed bank 0.95 → learned motif dictionary 0.90.</a:t>
+              <a:t>Behavior separates experts from proto-experts: naive 0.75 → designed 0.95 → learned motif dictionary 0.90.</a:t>
             </a:r>
           </a:p>
           <a:p>
             <a:pPr lvl="1"/>
             <a:r>
               <a:rPr sz="1500"/>
-              <a:t>Top signals are 3D-exploration kinematics — experts inspect from ~3× more viewpoints and are far more thorough.</a:t>
+              <a:t>Top signals are 3D-exploration kinematics — experts inspect from ~3× more viewpoints.</a:t>
             </a:r>
           </a:p>
           <a:p>
             <a:pPr lvl="1"/>
             <a:r>
               <a:rPr sz="1500"/>
-              <a:t>Only promoted students do the dense expert task at all — participation is itself a promotion signal.</a:t>
+              <a:t>Yet achieved accuracy is ceiling-clustered across two task types — a calibrated workforce converges on outcomes.</a:t>
             </a:r>
           </a:p>
           <a:p>
             <a:pPr lvl="1"/>
             <a:r>
               <a:rPr sz="1500"/>
-              <a:t>Behavior → per-task accuracy: ~no signal. Accuracy is ceiling-clustered across two task types (split distance AND fullyProofread labels).</a:t>
+              <a:t>Prospective &amp; GT-free: a task slow FOR THAT PERSON is significantly more error-prone (AUC 0.59, p&lt;0.001) — ‘subconscious uncertainty.’</a:t>
             </a:r>
           </a:p>
           <a:p>
             <a:pPr lvl="1"/>
             <a:r>
               <a:rPr sz="1500"/>
-              <a:t>Promoted students perform at expert accuracy (~310 nm); unpromoted scatter (~460) — consistent with agreement-gated promotion.</a:t>
+              <a:t>The language of proofreading ↔ the language of surgery (JIGSAWS; tacit knowledge): skill lives in HOW, not just WHAT.</a:t>
             </a:r>
           </a:p>
           <a:p>
@@ -6794,7 +6794,7 @@
                   <a:srgbClr val="1F4977"/>
                 </a:solidFill>
               </a:rPr>
-              <a:t>Expertise is a behavioral style; trained accuracy converges — so you must price the process.</a:t>
+              <a:t>Expertise is a behavioral style; per-task uncertainty stays legible even after competence converges.</a:t>
             </a:r>
           </a:p>
         </p:txBody>
@@ -6880,14 +6880,14 @@
             <a:pPr lvl="1"/>
             <a:r>
               <a:rPr sz="1500"/>
-              <a:t>Dual yield, structurally identical: a better connectome (mission) AND trained scientists (talent).</a:t>
+              <a:t>MICrONS relied on this workforce throughout — their proofreading underpins the MICrONS connectome (Nature, 2025).</a:t>
             </a:r>
           </a:p>
           <a:p>
             <a:pPr lvl="1"/>
             <a:r>
               <a:rPr sz="1500"/>
-              <a:t>MICrONS relied on this student workforce throughout — their proofreading underpins the MICrONS connectome (Nature, 2025) and downstream contributions.</a:t>
+              <a:t>Students we hired became co-authors and contributing members — Daniel Xenes (now leading NeuVue) is the exemplar.</a:t>
             </a:r>
           </a:p>
           <a:p>
@@ -6901,7 +6901,7 @@
             <a:pPr lvl="1"/>
             <a:r>
               <a:rPr sz="1500"/>
-              <a:t>Sits in APL’s NeuroTrailblazers / Research Incubator lineage; MERIT learning engineering (assess → mentor → promote).</a:t>
+              <a:t>APL NeuroTrailblazers / Research Incubator lineage; MERIT learning engineering (assess → mentor → promote).</a:t>
             </a:r>
           </a:p>
           <a:p>

</xml_diff>